<commit_message>
docs: add route-generation data-flow diagram and openable-history screenshots
- New on-brand data-flow diagram (generate candidates -> enrich -> score ->
  rank) added to the README ('How route generation works' section) and as a
  new slide in the defense deck (renumbered the 关键技术 series accordingly).
- New screenshots for the openable run history: the history list (now showing
  each run's date) and the run-detail screen (trail on a map + full stats),
  added to the README gallery.
</commit_message>
<xml_diff>
--- a/docs/答辩PPT-FreshLoop-CHENWEI-PAN.pptx
+++ b/docs/答辩PPT-FreshLoop-CHENWEI-PAN.pptx
@@ -11,6 +11,7 @@
     <p:sldId id="259" r:id="rId10"/>
     <p:sldId id="260" r:id="rId11"/>
     <p:sldId id="261" r:id="rId12"/>
+    <p:sldId id="272" r:id="rId23"/>
     <p:sldId id="262" r:id="rId13"/>
     <p:sldId id="263" r:id="rId14"/>
     <p:sldId id="264" r:id="rId15"/>
@@ -3477,7 +3478,7 @@
                 <a:ea typeface="微软雅黑"/>
                 <a:cs typeface="微软雅黑"/>
               </a:rPr>
-              <a:t>5. 关键技术（4）：可替换后端 + 多设备自适应</a:t>
+              <a:t>5. 关键技术（5）：可替换后端 + 多设备自适应</a:t>
             </a:r>
           </a:p>
         </p:txBody>
@@ -5911,6 +5912,208 @@
 </p:sld>
 </file>
 
+<file path=ppt/slides/slide17.xml><?xml version="1.0" encoding="utf-8"?>
+<p:sld xmlns:a="http://schemas.openxmlformats.org/drawingml/2006/main" xmlns:p="http://schemas.openxmlformats.org/presentationml/2006/main" xmlns:r="http://schemas.openxmlformats.org/officeDocument/2006/relationships">
+  <p:cSld>
+    <p:spTree>
+      <p:nvGrpSpPr>
+        <p:cNvPr id="1" name=""/>
+        <p:cNvGrpSpPr/>
+        <p:nvPr/>
+      </p:nvGrpSpPr>
+      <p:grpSpPr/>
+      <p:sp>
+        <p:nvSpPr>
+          <p:cNvPr id="2" name="Rectangle 1"/>
+          <p:cNvSpPr/>
+          <p:nvPr/>
+        </p:nvSpPr>
+        <p:spPr>
+          <a:xfrm>
+            <a:off x="0" y="0"/>
+            <a:ext cx="12191695" cy="128016"/>
+          </a:xfrm>
+          <a:prstGeom prst="rect">
+            <a:avLst/>
+          </a:prstGeom>
+          <a:solidFill>
+            <a:srgbClr val="0E9F6E"/>
+          </a:solidFill>
+          <a:ln>
+            <a:noFill/>
+          </a:ln>
+          <a:effectLst/>
+        </p:spPr>
+        <p:style>
+          <a:lnRef idx="1">
+            <a:schemeClr val="accent1"/>
+          </a:lnRef>
+          <a:fillRef idx="3">
+            <a:schemeClr val="accent1"/>
+          </a:fillRef>
+          <a:effectRef idx="2">
+            <a:schemeClr val="accent1"/>
+          </a:effectRef>
+          <a:fontRef idx="minor">
+            <a:schemeClr val="lt1"/>
+          </a:fontRef>
+        </p:style>
+        <p:txBody>
+          <a:bodyPr rtlCol="0" anchor="ctr"/>
+          <a:lstStyle/>
+          <a:p>
+            <a:pPr algn="ctr"/>
+          </a:p>
+        </p:txBody>
+      </p:sp>
+      <p:sp>
+        <p:nvSpPr>
+          <p:cNvPr id="3" name="TextBox 2"/>
+          <p:cNvSpPr txBox="1"/>
+          <p:nvPr/>
+        </p:nvSpPr>
+        <p:spPr>
+          <a:xfrm>
+            <a:off x="640080" y="384048"/>
+            <a:ext cx="10972800" cy="822960"/>
+          </a:xfrm>
+          <a:prstGeom prst="rect">
+            <a:avLst/>
+          </a:prstGeom>
+          <a:noFill/>
+        </p:spPr>
+        <p:txBody>
+          <a:bodyPr wrap="square" lIns="0" rIns="0">
+            <a:spAutoFit/>
+          </a:bodyPr>
+          <a:lstStyle/>
+          <a:p>
+            <a:r>
+              <a:rPr sz="2800" b="1">
+                <a:solidFill>
+                  <a:srgbClr val="0F1F1A"/>
+                </a:solidFill>
+                <a:latin typeface="Segoe UI"/>
+                <a:ea typeface="微软雅黑"/>
+                <a:cs typeface="微软雅黑"/>
+              </a:rPr>
+              <a:t>5. 关键技术（1）：路线生成流程</a:t>
+            </a:r>
+          </a:p>
+        </p:txBody>
+      </p:sp>
+      <p:sp>
+        <p:nvSpPr>
+          <p:cNvPr id="4" name="TextBox 3"/>
+          <p:cNvSpPr txBox="1"/>
+          <p:nvPr/>
+        </p:nvSpPr>
+        <p:spPr>
+          <a:xfrm>
+            <a:off x="640080" y="6419088"/>
+            <a:ext cx="10972800" cy="365760"/>
+          </a:xfrm>
+          <a:prstGeom prst="rect">
+            <a:avLst/>
+          </a:prstGeom>
+          <a:noFill/>
+        </p:spPr>
+        <p:txBody>
+          <a:bodyPr wrap="square" lIns="0" rIns="0">
+            <a:spAutoFit/>
+          </a:bodyPr>
+          <a:lstStyle/>
+          <a:p>
+            <a:r>
+              <a:rPr sz="1000" b="0">
+                <a:solidFill>
+                  <a:srgbClr val="5B6B66"/>
+                </a:solidFill>
+                <a:latin typeface="Segoe UI"/>
+                <a:ea typeface="微软雅黑"/>
+                <a:cs typeface="微软雅黑"/>
+              </a:rPr>
+              <a:t>FreshLoop 智能跑步路线生成器  ·  CHENWEI PAN  ·  移动应用设计与实现</a:t>
+            </a:r>
+          </a:p>
+        </p:txBody>
+      </p:sp>
+      <p:sp>
+        <p:nvSpPr>
+          <p:cNvPr id="5" name="Rectangle 4"/>
+          <p:cNvSpPr/>
+          <p:nvPr/>
+        </p:nvSpPr>
+        <p:spPr>
+          <a:xfrm>
+            <a:off x="640080" y="6382512"/>
+            <a:ext cx="10908792" cy="12700"/>
+          </a:xfrm>
+          <a:prstGeom prst="rect">
+            <a:avLst/>
+          </a:prstGeom>
+          <a:solidFill>
+            <a:srgbClr val="DDE3E1"/>
+          </a:solidFill>
+          <a:ln>
+            <a:noFill/>
+          </a:ln>
+          <a:effectLst/>
+        </p:spPr>
+        <p:style>
+          <a:lnRef idx="1">
+            <a:schemeClr val="accent1"/>
+          </a:lnRef>
+          <a:fillRef idx="3">
+            <a:schemeClr val="accent1"/>
+          </a:fillRef>
+          <a:effectRef idx="2">
+            <a:schemeClr val="accent1"/>
+          </a:effectRef>
+          <a:fontRef idx="minor">
+            <a:schemeClr val="lt1"/>
+          </a:fontRef>
+        </p:style>
+        <p:txBody>
+          <a:bodyPr rtlCol="0" anchor="ctr"/>
+          <a:lstStyle/>
+          <a:p>
+            <a:pPr algn="ctr"/>
+          </a:p>
+        </p:txBody>
+      </p:sp>
+      <p:pic>
+        <p:nvPicPr>
+          <p:cNvPr id="6" name="Picture 5" descr="route-gen-flow.png"/>
+          <p:cNvPicPr>
+            <a:picLocks noChangeAspect="1"/>
+          </p:cNvPicPr>
+          <p:nvPr/>
+        </p:nvPicPr>
+        <p:blipFill>
+          <a:blip r:embed="rId2"/>
+          <a:stretch>
+            <a:fillRect/>
+          </a:stretch>
+        </p:blipFill>
+        <p:spPr>
+          <a:xfrm>
+            <a:off x="3722762" y="1371600"/>
+            <a:ext cx="4746171" cy="4983480"/>
+          </a:xfrm>
+          <a:prstGeom prst="rect">
+            <a:avLst/>
+          </a:prstGeom>
+        </p:spPr>
+      </p:pic>
+    </p:spTree>
+  </p:cSld>
+  <p:clrMapOvr>
+    <a:masterClrMapping/>
+  </p:clrMapOvr>
+</p:sld>
+</file>
+
 <file path=ppt/slides/slide2.xml><?xml version="1.0" encoding="utf-8"?>
 <p:sld xmlns:a="http://schemas.openxmlformats.org/drawingml/2006/main" xmlns:p="http://schemas.openxmlformats.org/presentationml/2006/main" xmlns:r="http://schemas.openxmlformats.org/officeDocument/2006/relationships">
   <p:cSld>
@@ -8233,7 +8436,7 @@
                 <a:ea typeface="微软雅黑"/>
                 <a:cs typeface="微软雅黑"/>
               </a:rPr>
-              <a:t>5. 关键技术（1）：三轴可解释评分模型</a:t>
+              <a:t>5. 关键技术（2）：三轴可解释评分模型</a:t>
             </a:r>
           </a:p>
         </p:txBody>
@@ -8637,7 +8840,7 @@
                 <a:ea typeface="微软雅黑"/>
                 <a:cs typeface="微软雅黑"/>
               </a:rPr>
-              <a:t>5. 关键技术（2）：多源外部数据 + 可测试性</a:t>
+              <a:t>5. 关键技术（3）：多源外部数据 + 可测试性</a:t>
             </a:r>
           </a:p>
         </p:txBody>
@@ -8983,7 +9186,7 @@
                 <a:ea typeface="微软雅黑"/>
                 <a:cs typeface="微软雅黑"/>
               </a:rPr>
-              <a:t>5. 关键技术（3）：Firebase 鉴权 + 按用户云同步</a:t>
+              <a:t>5. 关键技术（4）：Firebase 鉴权 + 按用户云同步</a:t>
             </a:r>
           </a:p>
         </p:txBody>

</xml_diff>